<commit_message>
Add the live demo and repository links to the report, deck and README
Co-Authored-By: Claude Opus 5.5 <noreply@anthropic.com>
</commit_message>
<xml_diff>
--- a/docs/review2/BranchLab_Review2_Presentation.pptx
+++ b/docs/review2/BranchLab_Review2_Presentation.pptx
@@ -1597,7 +1597,7 @@
           <a:p>
             <a:r>
               <a:rPr lang="en-US" dirty="0"/>
-              <a:t>Thank the audience and take questions. For the demo: start the backend with python -m uvicorn api:app --reload, and the frontend with npm run dev in the frontend folder, then open localhost:5173. Suggested flow: run the Python starter to show 17, 18 and 19 and full coverage; then paste examples/c/bank.c with 20 tests and show that every menu option runs, the coverage tab with branch and statement coverage, and the suggestions marked not reached for deposit and withdraw; finally toggle dark mode. Fill in the repository link before presenting.</a:t>
+              <a:t>Thank the audience and take questions. For the demo: open https://branchlab-ggon.onrender.com about two minutes early, since the free server sleeps when idle. As a backup, run it locally: start the backend with python -m uvicorn api:app --reload, and the frontend with npm run dev in the frontend folder, then open localhost:5173. Suggested flow: run the Python starter to show 17, 18 and 19 and full coverage; then paste examples/c/bank.c with 20 tests and show that every menu option runs, the coverage tab with branch and statement coverage, and the suggestions marked not reached for deposit and withdraw; finally toggle dark mode. Fill in the repository link before presenting.</a:t>
             </a:r>
             <a:endParaRPr lang="en-US" dirty="0"/>
           </a:p>
@@ -9681,7 +9681,7 @@
         <p:spPr>
           <a:xfrm>
             <a:off x="1051560" y="5532120"/>
-            <a:ext cx="7040880" cy="411480"/>
+            <a:ext cx="7040880" cy="548640"/>
           </a:xfrm>
           <a:prstGeom prst="rect">
             <a:avLst/>
@@ -9702,7 +9702,38 @@
                   <a:schemeClr val="tx2"/>
                 </a:solidFill>
               </a:rPr>
-              <a:t>Source: [GitHub repository link]</a:t>
+              <a:t>Live demo: </a:t>
+            </a:r>
+            <a:r>
+              <a:rPr lang="en-US" sz="1600" dirty="0">
+                <a:solidFill>
+                  <a:schemeClr val="tx2"/>
+                </a:solidFill>
+                <a:hlinkClick r:id="rIdBLDemo"/>
+              </a:rPr>
+              <a:t>branchlab-ggon.onrender.com</a:t>
+            </a:r>
+          </a:p>
+          <a:p>
+            <a:pPr indent="0" marL="0">
+              <a:buNone/>
+            </a:pPr>
+            <a:r>
+              <a:rPr lang="en-US" sz="1600" dirty="0">
+                <a:solidFill>
+                  <a:schemeClr val="tx2"/>
+                </a:solidFill>
+              </a:rPr>
+              <a:t>Source: </a:t>
+            </a:r>
+            <a:r>
+              <a:rPr lang="en-US" sz="1600" dirty="0">
+                <a:solidFill>
+                  <a:schemeClr val="tx2"/>
+                </a:solidFill>
+                <a:hlinkClick r:id="rIdBLRepo"/>
+              </a:rPr>
+              <a:t>github.com/SnehaGEE/ast-test-generator</a:t>
             </a:r>
             <a:endParaRPr lang="en-US" sz="1600" dirty="0"/>
           </a:p>

</xml_diff>